<commit_message>
docs: update architectural documentation and README to reflect microservice infrastructure and cloud deployment strategy
</commit_message>
<xml_diff>
--- a/docs/Architekturmodellierung.pptx
+++ b/docs/Architekturmodellierung.pptx
@@ -3196,7 +3196,7 @@
                   <a:srgbClr val="9CB0BC"/>
                 </a:solidFill>
               </a:rPr>
-              <a:t>3-Tier-Microservice-Webshop  ·  SSR Frontend, 7 Services, MySQL / Redis / MinIO</a:t>
+              <a:t>3-Tier-Microservice-Webshop  ·  SSR Frontend, 7 Services, 2x MySQL / Redis / MinIO</a:t>
             </a:r>
           </a:p>
         </p:txBody>
@@ -4216,8 +4216,8 @@
         </p:nvSpPr>
         <p:spPr>
           <a:xfrm>
-            <a:off x="1584198" y="5532120"/>
-            <a:ext cx="2194560" cy="868680"/>
+            <a:off x="1194206" y="5532120"/>
+            <a:ext cx="1828800" cy="868680"/>
           </a:xfrm>
           <a:prstGeom prst="can">
             <a:avLst/>
@@ -4256,7 +4256,7 @@
                   <a:srgbClr val="FFFFFF"/>
                 </a:solidFill>
               </a:rPr>
-              <a:t>MySQL  ·  Product DB</a:t>
+              <a:t>MySQL  ·  Catalog</a:t>
             </a:r>
           </a:p>
           <a:p>
@@ -4267,7 +4267,7 @@
                   <a:srgbClr val="ECF3F7"/>
                 </a:solidFill>
               </a:rPr>
-              <a:t>Database-per-Service (ADR7)</a:t>
+              <a:t>aether_motors  ·  ADR7</a:t>
             </a:r>
           </a:p>
         </p:txBody>
@@ -4280,8 +4280,8 @@
         </p:nvSpPr>
         <p:spPr>
           <a:xfrm>
-            <a:off x="4997196" y="5532120"/>
-            <a:ext cx="2194560" cy="868680"/>
+            <a:off x="3851452" y="5532120"/>
+            <a:ext cx="1828800" cy="868680"/>
           </a:xfrm>
           <a:prstGeom prst="can">
             <a:avLst/>
@@ -4320,7 +4320,7 @@
                   <a:srgbClr val="FFFFFF"/>
                 </a:solidFill>
               </a:rPr>
-              <a:t>Redis  ·  Cart Cache</a:t>
+              <a:t>MySQL  ·  Orders</a:t>
             </a:r>
           </a:p>
           <a:p>
@@ -4331,7 +4331,7 @@
                   <a:srgbClr val="ECF3F7"/>
                 </a:solidFill>
               </a:rPr>
-              <a:t>Sliding TTL  ·  ADR8</a:t>
+              <a:t>aether_orders  ·  ADR11</a:t>
             </a:r>
           </a:p>
         </p:txBody>
@@ -4344,8 +4344,8 @@
         </p:nvSpPr>
         <p:spPr>
           <a:xfrm>
-            <a:off x="8410194" y="5532120"/>
-            <a:ext cx="2194560" cy="868680"/>
+            <a:off x="6508699" y="5532120"/>
+            <a:ext cx="1828800" cy="868680"/>
           </a:xfrm>
           <a:prstGeom prst="can">
             <a:avLst/>
@@ -4384,7 +4384,71 @@
                   <a:srgbClr val="FFFFFF"/>
                 </a:solidFill>
               </a:rPr>
-              <a:t>MinIO  ·  Media Bucket</a:t>
+              <a:t>Redis  ·  Cart</a:t>
+            </a:r>
+          </a:p>
+          <a:p>
+            <a:pPr algn="ctr"/>
+            <a:r>
+              <a:rPr sz="700">
+                <a:solidFill>
+                  <a:srgbClr val="ECF3F7"/>
+                </a:solidFill>
+              </a:rPr>
+              <a:t>Sliding TTL  ·  ADR8</a:t>
+            </a:r>
+          </a:p>
+        </p:txBody>
+      </p:sp>
+      <p:sp>
+        <p:nvSpPr>
+          <p:cNvPr id="28" name="Can 27"/>
+          <p:cNvSpPr/>
+          <p:nvPr/>
+        </p:nvSpPr>
+        <p:spPr>
+          <a:xfrm>
+            <a:off x="9165945" y="5532120"/>
+            <a:ext cx="1828800" cy="868680"/>
+          </a:xfrm>
+          <a:prstGeom prst="can">
+            <a:avLst/>
+          </a:prstGeom>
+          <a:solidFill>
+            <a:srgbClr val="004E5A"/>
+          </a:solidFill>
+          <a:ln>
+            <a:solidFill>
+              <a:srgbClr val="00DAF8"/>
+            </a:solidFill>
+          </a:ln>
+        </p:spPr>
+        <p:style>
+          <a:lnRef idx="1">
+            <a:schemeClr val="accent1"/>
+          </a:lnRef>
+          <a:fillRef idx="3">
+            <a:schemeClr val="accent1"/>
+          </a:fillRef>
+          <a:effectRef idx="2">
+            <a:schemeClr val="accent1"/>
+          </a:effectRef>
+          <a:fontRef idx="minor">
+            <a:schemeClr val="lt1"/>
+          </a:fontRef>
+        </p:style>
+        <p:txBody>
+          <a:bodyPr rtlCol="0" anchor="ctr" wrap="square"/>
+          <a:lstStyle/>
+          <a:p>
+            <a:pPr algn="ctr"/>
+            <a:r>
+              <a:rPr sz="1000" b="1">
+                <a:solidFill>
+                  <a:srgbClr val="FFFFFF"/>
+                </a:solidFill>
+              </a:rPr>
+              <a:t>MinIO  ·  Media</a:t>
             </a:r>
           </a:p>
           <a:p>
@@ -4402,14 +4466,14 @@
       </p:sp>
       <p:cxnSp>
         <p:nvCxnSpPr>
-          <p:cNvPr id="28" name="Connector 27"/>
+          <p:cNvPr id="29" name="Connector 28"/>
           <p:cNvCxnSpPr/>
           <p:nvPr/>
         </p:nvCxnSpPr>
         <p:spPr>
           <a:xfrm>
             <a:off x="2053742.4" y="3840480"/>
-            <a:ext cx="627735.6000000001" cy="1691640"/>
+            <a:ext cx="54864.0" cy="1691640"/>
           </a:xfrm>
           <a:prstGeom prst="bentConnector3">
             <a:avLst/>
@@ -4438,13 +4502,13 @@
       </p:cxnSp>
       <p:sp>
         <p:nvSpPr>
-          <p:cNvPr id="29" name="TextBox 28"/>
+          <p:cNvPr id="30" name="TextBox 29"/>
           <p:cNvSpPr txBox="1"/>
           <p:nvPr/>
         </p:nvSpPr>
         <p:spPr>
           <a:xfrm>
-            <a:off x="2001850" y="4584700"/>
+            <a:off x="1715414" y="4584700"/>
             <a:ext cx="731520" cy="177800"/>
           </a:xfrm>
           <a:prstGeom prst="rect">
@@ -4472,14 +4536,14 @@
       </p:sp>
       <p:cxnSp>
         <p:nvCxnSpPr>
-          <p:cNvPr id="30" name="Connector 29"/>
+          <p:cNvPr id="31" name="Connector 30"/>
           <p:cNvCxnSpPr/>
           <p:nvPr/>
         </p:nvCxnSpPr>
         <p:spPr>
           <a:xfrm>
             <a:off x="4747564.8" y="3840480"/>
-            <a:ext cx="1346911.2000000002" cy="1691640"/>
+            <a:ext cx="2675534.4000000004" cy="1691640"/>
           </a:xfrm>
           <a:prstGeom prst="bentConnector3">
             <a:avLst/>
@@ -4508,13 +4572,13 @@
       </p:cxnSp>
       <p:sp>
         <p:nvSpPr>
-          <p:cNvPr id="31" name="TextBox 30"/>
+          <p:cNvPr id="32" name="TextBox 31"/>
           <p:cNvSpPr txBox="1"/>
           <p:nvPr/>
         </p:nvSpPr>
         <p:spPr>
           <a:xfrm>
-            <a:off x="5055260" y="4584700"/>
+            <a:off x="5719572" y="4584700"/>
             <a:ext cx="731520" cy="177800"/>
           </a:xfrm>
           <a:prstGeom prst="rect">
@@ -4542,14 +4606,14 @@
       </p:sp>
       <p:cxnSp>
         <p:nvCxnSpPr>
-          <p:cNvPr id="32" name="Connector 31"/>
+          <p:cNvPr id="33" name="Connector 32"/>
           <p:cNvCxnSpPr/>
           <p:nvPr/>
         </p:nvCxnSpPr>
         <p:spPr>
           <a:xfrm flipH="1">
-            <a:off x="9507474.0" y="3840480"/>
-            <a:ext cx="627735.5999999996" cy="1691640"/>
+            <a:off x="4765852.8" y="3840480"/>
+            <a:ext cx="2675534.4000000004" cy="1691640"/>
           </a:xfrm>
           <a:prstGeom prst="bentConnector3">
             <a:avLst/>
@@ -4578,13 +4642,13 @@
       </p:cxnSp>
       <p:sp>
         <p:nvSpPr>
-          <p:cNvPr id="33" name="TextBox 32"/>
+          <p:cNvPr id="34" name="TextBox 33"/>
           <p:cNvSpPr txBox="1"/>
           <p:nvPr/>
         </p:nvSpPr>
         <p:spPr>
           <a:xfrm>
-            <a:off x="9455581" y="4584700"/>
+            <a:off x="5737860" y="4584700"/>
             <a:ext cx="731520" cy="177800"/>
           </a:xfrm>
           <a:prstGeom prst="rect">
@@ -4605,6 +4669,76 @@
                   <a:srgbClr val="9CB0BC"/>
                 </a:solidFill>
               </a:rPr>
+              <a:t>JDBC/SQL</a:t>
+            </a:r>
+          </a:p>
+        </p:txBody>
+      </p:sp>
+      <p:cxnSp>
+        <p:nvCxnSpPr>
+          <p:cNvPr id="35" name="Connector 34"/>
+          <p:cNvCxnSpPr/>
+          <p:nvPr/>
+        </p:nvCxnSpPr>
+        <p:spPr>
+          <a:xfrm flipH="1">
+            <a:off x="10080345.6" y="3840480"/>
+            <a:ext cx="54864.0" cy="1691640"/>
+          </a:xfrm>
+          <a:prstGeom prst="bentConnector3">
+            <a:avLst/>
+          </a:prstGeom>
+          <a:ln w="15875">
+            <a:solidFill>
+              <a:srgbClr val="00DAF8"/>
+            </a:solidFill>
+            <a:tailEnd type="triangle" w="med" h="med"/>
+          </a:ln>
+        </p:spPr>
+        <p:style>
+          <a:lnRef idx="2">
+            <a:schemeClr val="accent1"/>
+          </a:lnRef>
+          <a:fillRef idx="0">
+            <a:schemeClr val="accent1"/>
+          </a:fillRef>
+          <a:effectRef idx="1">
+            <a:schemeClr val="accent1"/>
+          </a:effectRef>
+          <a:fontRef idx="minor">
+            <a:schemeClr val="tx1"/>
+          </a:fontRef>
+        </p:style>
+      </p:cxnSp>
+      <p:sp>
+        <p:nvSpPr>
+          <p:cNvPr id="36" name="TextBox 35"/>
+          <p:cNvSpPr txBox="1"/>
+          <p:nvPr/>
+        </p:nvSpPr>
+        <p:spPr>
+          <a:xfrm>
+            <a:off x="9742017" y="4584700"/>
+            <a:ext cx="731520" cy="177800"/>
+          </a:xfrm>
+          <a:prstGeom prst="rect">
+            <a:avLst/>
+          </a:prstGeom>
+          <a:noFill/>
+        </p:spPr>
+        <p:txBody>
+          <a:bodyPr wrap="none" lIns="0" rIns="0" tIns="0" bIns="0">
+            <a:spAutoFit/>
+          </a:bodyPr>
+          <a:lstStyle/>
+          <a:p>
+            <a:pPr algn="ctr"/>
+            <a:r>
+              <a:rPr sz="700" i="1">
+                <a:solidFill>
+                  <a:srgbClr val="9CB0BC"/>
+                </a:solidFill>
+              </a:rPr>
               <a:t>S3 API</a:t>
             </a:r>
           </a:p>
@@ -4612,14 +4746,14 @@
       </p:sp>
       <p:sp>
         <p:nvSpPr>
-          <p:cNvPr id="34" name="Rounded Rectangle 33"/>
+          <p:cNvPr id="37" name="Rounded Rectangle 36"/>
           <p:cNvSpPr/>
           <p:nvPr/>
         </p:nvSpPr>
         <p:spPr>
           <a:xfrm>
-            <a:off x="8410194" y="5212080"/>
-            <a:ext cx="2194560" cy="256032"/>
+            <a:off x="9165945" y="5212080"/>
+            <a:ext cx="1828800" cy="256032"/>
           </a:xfrm>
           <a:prstGeom prst="roundRect">
             <a:avLst/>
@@ -4665,7 +4799,7 @@
       </p:sp>
       <p:sp>
         <p:nvSpPr>
-          <p:cNvPr id="35" name="TextBox 34"/>
+          <p:cNvPr id="38" name="TextBox 37"/>
           <p:cNvSpPr txBox="1"/>
           <p:nvPr/>
         </p:nvSpPr>
@@ -4821,7 +4955,7 @@
                   <a:srgbClr val="9CB0BC"/>
                 </a:solidFill>
               </a:rPr>
-              <a:t>Komponenten + Ziel-Cloud-Services (DDR1–DDR8)  ·  Lokal: Docker Compose  ·  Prod: AWS</a:t>
+              <a:t>Komponenten + Ziel-Cloud-Services (DDR1–DDR9)  ·  Lokal: Docker Compose  ·  Prod: AWS</a:t>
             </a:r>
           </a:p>
         </p:txBody>
@@ -5665,8 +5799,8 @@
         </p:nvSpPr>
         <p:spPr>
           <a:xfrm>
-            <a:off x="1584198" y="5349240"/>
-            <a:ext cx="2194560" cy="640080"/>
+            <a:off x="1194206" y="5349240"/>
+            <a:ext cx="1828800" cy="640080"/>
           </a:xfrm>
           <a:prstGeom prst="can">
             <a:avLst/>
@@ -5716,7 +5850,7 @@
                   <a:srgbClr val="ECF3F7"/>
                 </a:solidFill>
               </a:rPr>
-              <a:t>Product DB</a:t>
+              <a:t>Catalog</a:t>
             </a:r>
           </a:p>
         </p:txBody>
@@ -5729,8 +5863,8 @@
         </p:nvSpPr>
         <p:spPr>
           <a:xfrm>
-            <a:off x="4997196" y="5349240"/>
-            <a:ext cx="2194560" cy="640080"/>
+            <a:off x="3851452" y="5349240"/>
+            <a:ext cx="1828800" cy="640080"/>
           </a:xfrm>
           <a:prstGeom prst="can">
             <a:avLst/>
@@ -5769,7 +5903,7 @@
                   <a:srgbClr val="FFFFFF"/>
                 </a:solidFill>
               </a:rPr>
-              <a:t>Redis</a:t>
+              <a:t>MySQL</a:t>
             </a:r>
           </a:p>
           <a:p>
@@ -5780,7 +5914,7 @@
                   <a:srgbClr val="ECF3F7"/>
                 </a:solidFill>
               </a:rPr>
-              <a:t>Cart Cache</a:t>
+              <a:t>Orders</a:t>
             </a:r>
           </a:p>
         </p:txBody>
@@ -5793,8 +5927,8 @@
         </p:nvSpPr>
         <p:spPr>
           <a:xfrm>
-            <a:off x="8410194" y="5349240"/>
-            <a:ext cx="2194560" cy="640080"/>
+            <a:off x="6508699" y="5349240"/>
+            <a:ext cx="1828800" cy="640080"/>
           </a:xfrm>
           <a:prstGeom prst="can">
             <a:avLst/>
@@ -5833,7 +5967,7 @@
                   <a:srgbClr val="FFFFFF"/>
                 </a:solidFill>
               </a:rPr>
-              <a:t>MinIO</a:t>
+              <a:t>Redis</a:t>
             </a:r>
           </a:p>
           <a:p>
@@ -5844,21 +5978,85 @@
                   <a:srgbClr val="ECF3F7"/>
                 </a:solidFill>
               </a:rPr>
-              <a:t>Media Bucket</a:t>
-            </a:r>
-          </a:p>
-        </p:txBody>
-      </p:sp>
-      <p:sp>
-        <p:nvSpPr>
-          <p:cNvPr id="25" name="Rounded Rectangle 24"/>
+              <a:t>Cart Cache</a:t>
+            </a:r>
+          </a:p>
+        </p:txBody>
+      </p:sp>
+      <p:sp>
+        <p:nvSpPr>
+          <p:cNvPr id="25" name="Can 24"/>
           <p:cNvSpPr/>
           <p:nvPr/>
         </p:nvSpPr>
         <p:spPr>
           <a:xfrm>
-            <a:off x="1538478" y="6062472"/>
-            <a:ext cx="2286000" cy="320040"/>
+            <a:off x="9165945" y="5349240"/>
+            <a:ext cx="1828800" cy="640080"/>
+          </a:xfrm>
+          <a:prstGeom prst="can">
+            <a:avLst/>
+          </a:prstGeom>
+          <a:solidFill>
+            <a:srgbClr val="004E5A"/>
+          </a:solidFill>
+          <a:ln>
+            <a:solidFill>
+              <a:srgbClr val="00DAF8"/>
+            </a:solidFill>
+          </a:ln>
+        </p:spPr>
+        <p:style>
+          <a:lnRef idx="1">
+            <a:schemeClr val="accent1"/>
+          </a:lnRef>
+          <a:fillRef idx="3">
+            <a:schemeClr val="accent1"/>
+          </a:fillRef>
+          <a:effectRef idx="2">
+            <a:schemeClr val="accent1"/>
+          </a:effectRef>
+          <a:fontRef idx="minor">
+            <a:schemeClr val="lt1"/>
+          </a:fontRef>
+        </p:style>
+        <p:txBody>
+          <a:bodyPr rtlCol="0" anchor="ctr" wrap="square"/>
+          <a:lstStyle/>
+          <a:p>
+            <a:pPr algn="ctr"/>
+            <a:r>
+              <a:rPr sz="1000" b="1">
+                <a:solidFill>
+                  <a:srgbClr val="FFFFFF"/>
+                </a:solidFill>
+              </a:rPr>
+              <a:t>MinIO</a:t>
+            </a:r>
+          </a:p>
+          <a:p>
+            <a:pPr algn="ctr"/>
+            <a:r>
+              <a:rPr sz="700">
+                <a:solidFill>
+                  <a:srgbClr val="ECF3F7"/>
+                </a:solidFill>
+              </a:rPr>
+              <a:t>Media Bucket</a:t>
+            </a:r>
+          </a:p>
+        </p:txBody>
+      </p:sp>
+      <p:sp>
+        <p:nvSpPr>
+          <p:cNvPr id="26" name="Rounded Rectangle 25"/>
+          <p:cNvSpPr/>
+          <p:nvPr/>
+        </p:nvSpPr>
+        <p:spPr>
+          <a:xfrm>
+            <a:off x="1148486" y="6062472"/>
+            <a:ext cx="1920240" cy="320040"/>
           </a:xfrm>
           <a:prstGeom prst="roundRect">
             <a:avLst/>
@@ -5904,14 +6102,14 @@
       </p:sp>
       <p:sp>
         <p:nvSpPr>
-          <p:cNvPr id="26" name="Rounded Rectangle 25"/>
+          <p:cNvPr id="27" name="Rounded Rectangle 26"/>
           <p:cNvSpPr/>
           <p:nvPr/>
         </p:nvSpPr>
         <p:spPr>
           <a:xfrm>
-            <a:off x="4951476" y="6062472"/>
-            <a:ext cx="2286000" cy="320040"/>
+            <a:off x="3805732" y="6062472"/>
+            <a:ext cx="1920240" cy="320040"/>
           </a:xfrm>
           <a:prstGeom prst="roundRect">
             <a:avLst/>
@@ -5950,21 +6148,21 @@
                   <a:srgbClr val="FFB64D"/>
                 </a:solidFill>
               </a:rPr>
-              <a:t>AWS ElastiCache for Redis (DDR6)</a:t>
-            </a:r>
-          </a:p>
-        </p:txBody>
-      </p:sp>
-      <p:sp>
-        <p:nvSpPr>
-          <p:cNvPr id="27" name="Rounded Rectangle 26"/>
+              <a:t>AWS RDS for MySQL (DDR9)</a:t>
+            </a:r>
+          </a:p>
+        </p:txBody>
+      </p:sp>
+      <p:sp>
+        <p:nvSpPr>
+          <p:cNvPr id="28" name="Rounded Rectangle 27"/>
           <p:cNvSpPr/>
           <p:nvPr/>
         </p:nvSpPr>
         <p:spPr>
           <a:xfrm>
-            <a:off x="8364474" y="6062472"/>
-            <a:ext cx="2286000" cy="320040"/>
+            <a:off x="6462979" y="6062472"/>
+            <a:ext cx="1920240" cy="320040"/>
           </a:xfrm>
           <a:prstGeom prst="roundRect">
             <a:avLst/>
@@ -6003,14 +6201,67 @@
                   <a:srgbClr val="FFB64D"/>
                 </a:solidFill>
               </a:rPr>
-              <a:t>AWS S3 (DDR7)  ·  API-kompatibel</a:t>
-            </a:r>
-          </a:p>
-        </p:txBody>
-      </p:sp>
-      <p:sp>
-        <p:nvSpPr>
-          <p:cNvPr id="28" name="TextBox 27"/>
+              <a:t>AWS ElastiCache (DDR6)</a:t>
+            </a:r>
+          </a:p>
+        </p:txBody>
+      </p:sp>
+      <p:sp>
+        <p:nvSpPr>
+          <p:cNvPr id="29" name="Rounded Rectangle 28"/>
+          <p:cNvSpPr/>
+          <p:nvPr/>
+        </p:nvSpPr>
+        <p:spPr>
+          <a:xfrm>
+            <a:off x="9120225" y="6062472"/>
+            <a:ext cx="1920240" cy="320040"/>
+          </a:xfrm>
+          <a:prstGeom prst="roundRect">
+            <a:avLst/>
+          </a:prstGeom>
+          <a:solidFill>
+            <a:srgbClr val="0D1B2A"/>
+          </a:solidFill>
+          <a:ln w="6350">
+            <a:solidFill>
+              <a:srgbClr val="FFB64D"/>
+            </a:solidFill>
+          </a:ln>
+        </p:spPr>
+        <p:style>
+          <a:lnRef idx="1">
+            <a:schemeClr val="accent1"/>
+          </a:lnRef>
+          <a:fillRef idx="3">
+            <a:schemeClr val="accent1"/>
+          </a:fillRef>
+          <a:effectRef idx="2">
+            <a:schemeClr val="accent1"/>
+          </a:effectRef>
+          <a:fontRef idx="minor">
+            <a:schemeClr val="lt1"/>
+          </a:fontRef>
+        </p:style>
+        <p:txBody>
+          <a:bodyPr rtlCol="0" anchor="ctr" wrap="square" lIns="50800" rIns="50800" tIns="25400" bIns="25400"/>
+          <a:lstStyle/>
+          <a:p>
+            <a:pPr algn="ctr"/>
+            <a:r>
+              <a:rPr sz="800" b="1">
+                <a:solidFill>
+                  <a:srgbClr val="FFB64D"/>
+                </a:solidFill>
+              </a:rPr>
+              <a:t>AWS S3 (DDR7)</a:t>
+            </a:r>
+          </a:p>
+        </p:txBody>
+      </p:sp>
+      <p:sp>
+        <p:nvSpPr>
+          <p:cNvPr id="30" name="TextBox 29"/>
           <p:cNvSpPr txBox="1"/>
           <p:nvPr/>
         </p:nvSpPr>

</xml_diff>